<commit_message>
Recolor LBG flowchart with larger text and use it in stage slide
Co-Authored-By: Claude Sonnet 5.5 <noreply@anthropic.com>
Claude-Session: https://claude.ai/code/session_01T6gEewJ8YaCdmnsfS34RJd
</commit_message>
<xml_diff>
--- a/results/seminar/figs/stages.pptx
+++ b/results/seminar/figs/stages.pptx
@@ -4429,7 +4429,7 @@
       </p:sp>
       <p:pic>
         <p:nvPicPr>
-          <p:cNvPr id="7" name="Image 0" descr="assets/ch3_fig33.png">    </p:cNvPr>
+          <p:cNvPr id="7" name="Image 0" descr="assets/lbg_flow_color.png">    </p:cNvPr>
           <p:cNvPicPr>
             <a:picLocks noChangeAspect="1"/>
           </p:cNvPicPr>
@@ -4443,8 +4443,8 @@
         </p:blipFill>
         <p:spPr>
           <a:xfrm>
-            <a:off x="827791" y="1325880"/>
-            <a:ext cx="6574018" cy="4800600"/>
+            <a:off x="749477" y="1325880"/>
+            <a:ext cx="6730646" cy="4800600"/>
           </a:xfrm>
           <a:prstGeom prst="rect">
             <a:avLst/>

</xml_diff>